<commit_message>
Improve all 5 episodes based on editorial review
- modeles: remove brittle GPT version numbers, merge redundant slides,
  replace heritage red card with wrong-mode cost warning
- outlook: add second card to Astuce 2, clarify QuickPart [CP] prefix,
  sharpen Tip3 (trier/réactif) vs Tip5 (planifier/proactif) distinction
- personas: translate English prompts to French, add author/date fields,
  swap generic personas for FI-specific roles (conformité, chef de projet),
  reorder slides so formula precedes before/after examples
- prompts-avances: soften unsourced error-reduction claim, improve ToT
  example to vendor selection (FI context), clarify CoT as starting point
- sharepoint-onedrive: lead with value not tech (Graph relegated to notes),
  fix app X placeholder to ServiceNow, add Teams as third data source,
  remove ChatGPT comparison, sharpen weekly challenge

Co-authored-by: Cursor <cursoragent@cursor.com>
</commit_message>
<xml_diff>
--- a/presentations/La_Minute_Copilot_Modeles.pptx
+++ b/presentations/La_Minute_Copilot_Modeles.pptx
@@ -10,7 +10,6 @@
     <p:sldId id="258" r:id="rId10"/>
     <p:sldId id="259" r:id="rId11"/>
     <p:sldId id="260" r:id="rId12"/>
-    <p:sldId id="261" r:id="rId13"/>
   </p:sldIdLst>
   <p:sldSz cx="12188952" cy="6858000" type="screen4x3"/>
   <p:notesSz cx="6858000" cy="9144000"/>
@@ -507,7 +506,7 @@
           <a:lstStyle/>
           <a:p>
             <a:r>
-              <a:t>Accueil: «Vous avez peut-être remarqué que Copilot propose plusieurs modes et modèles. Auto, Quick Response, Think Deeper... GPT-5.2 à 5.5. On démystifie ça en 5 minutes!»</a:t>
+              <a:t>Accueil: «Vous avez peut-être remarqué que Copilot propose plusieurs modes. Auto, Quick Response, Think Deeper... On démystifie ça en 5 minutes!»</a:t>
             </a:r>
           </a:p>
         </p:txBody>
@@ -577,7 +576,7 @@
           <a:lstStyle/>
           <a:p>
             <a:r>
-              <a:t>Montrer l'interface Copilot. Expliquer les 3 modes simplement. L'AUTO c'est le mode par défaut, Copilot choisit pour vous. Le QUICK c'est pour les questions rapides. Le THINK DEEPER c'est pour les problèmes complexes qui méritent une réflexion approfondie.</a:t>
+              <a:t>Montrer l'interface Copilot. Expliquer les 3 modes simplement. AUTO = le mode par défaut, Copilot choisit pour vous. QUICK = pour les questions rapides, réponse en secondes. THINK DEEPER = pour les problèmes complexes qui méritent une réflexion approfondie. Insister: la plupart du temps, Auto fait le bon choix à votre place.</a:t>
             </a:r>
           </a:p>
         </p:txBody>
@@ -647,7 +646,7 @@
           <a:lstStyle/>
           <a:p>
             <a:r>
-              <a:t>Expliquer la hiérarchie: 5.2 est l'ancien modèle encore disponible. 5.3 et 5.5 Quick sont rapides. 5.4 et 5.5 Think Deeper sont les modèles de raisonnement. L'important c'est de choisir le bon outil pour la bonne tâche — pas besoin de Think Deeper pour un courriel!</a:t>
+              <a:t>Adapter au contexte financier. Expliquer pourquoi Think Deeper est crucial pour l'analyse de risques mais inutile pour un courriel. Insister: mauvais choix de mode = perte de temps. Quick Response pour un rapport de conformité = risque d'erreur. Think Deeper pour un courriel = attente de 60 secondes sans raison. Auto gère ça pour vous.</a:t>
             </a:r>
           </a:p>
         </p:txBody>
@@ -717,7 +716,7 @@
           <a:lstStyle/>
           <a:p>
             <a:r>
-              <a:t>Adapter au contexte financier. Expliquer pourquoi Think Deeper est crucial pour l'analyse de risques mais overkill pour un courriel. Insister: AUTO fait le bon choix 80% du temps. Les experts peuvent forcer le mode pour des cas spécifiques.</a:t>
+              <a:t>Rappeler que le mode est persistant — si vous passez en Think Deeper, il reste pour la session. Pensez à vérifier avant de commencer! Aussi: les prompts longs et détaillés bénéficient plus du Think Deeper. Pour la conformité, le Think Deeper est plus fiable car il raisonne plus longtemps. Astuce de pro: en mode Think Deeper, ajoutez un persona (chef de projet, auditeur interne) pour des résultats encore plus ciblés.</a:t>
             </a:r>
           </a:p>
         </p:txBody>
@@ -787,77 +786,7 @@
           <a:lstStyle/>
           <a:p>
             <a:r>
-              <a:t>Rappeler que le mode est persistant — si vous passez en Think Deeper, il reste pour la session suivante. Pensez à revenir à Auto! Aussi: les prompts longs et détaillés bénéficient plus du Think Deeper. Pour la conformité, le Think Deeper est plus fiable car il raisonne plus longtemps.</a:t>
-            </a:r>
-          </a:p>
-        </p:txBody>
-      </p:sp>
-      <p:sp>
-        <p:nvSpPr>
-          <p:cNvPr id="4" name="Slide Number Placeholder 3"/>
-          <p:cNvSpPr>
-            <a:spLocks noGrp="1"/>
-          </p:cNvSpPr>
-          <p:nvPr>
-            <p:ph type="sldNum" idx="5" sz="quarter"/>
-          </p:nvPr>
-        </p:nvSpPr>
-        <p:spPr/>
-      </p:sp>
-    </p:spTree>
-  </p:cSld>
-  <p:clrMapOvr>
-    <a:masterClrMapping/>
-  </p:clrMapOvr>
-</p:notes>
-</file>
-
-<file path=ppt/notesSlides/notesSlide6.xml><?xml version="1.0" encoding="utf-8"?>
-<p:notes xmlns:a="http://schemas.openxmlformats.org/drawingml/2006/main" xmlns:p="http://schemas.openxmlformats.org/presentationml/2006/main" xmlns:r="http://schemas.openxmlformats.org/officeDocument/2006/relationships">
-  <p:cSld>
-    <p:spTree>
-      <p:nvGrpSpPr>
-        <p:cNvPr id="1" name=""/>
-        <p:cNvGrpSpPr/>
-        <p:nvPr/>
-      </p:nvGrpSpPr>
-      <p:grpSpPr>
-        <a:xfrm>
-          <a:off x="0" y="0"/>
-          <a:ext cx="0" cy="0"/>
-          <a:chOff x="0" y="0"/>
-          <a:chExt cx="0" cy="0"/>
-        </a:xfrm>
-      </p:grpSpPr>
-      <p:sp>
-        <p:nvSpPr>
-          <p:cNvPr id="2" name="Slide Image Placeholder 1"/>
-          <p:cNvSpPr>
-            <a:spLocks noGrp="1"/>
-          </p:cNvSpPr>
-          <p:nvPr>
-            <p:ph type="sldImg" idx="2"/>
-          </p:nvPr>
-        </p:nvSpPr>
-        <p:spPr/>
-      </p:sp>
-      <p:sp>
-        <p:nvSpPr>
-          <p:cNvPr id="3" name="Notes Placeholder 2"/>
-          <p:cNvSpPr>
-            <a:spLocks noGrp="1"/>
-          </p:cNvSpPr>
-          <p:nvPr>
-            <p:ph type="body" idx="3" sz="quarter"/>
-          </p:nvPr>
-        </p:nvSpPr>
-        <p:spPr/>
-        <p:txBody>
-          <a:bodyPr/>
-          <a:lstStyle/>
-          <a:p>
-            <a:r>
-              <a:t>Résumé: Auto par défaut, Quick pour la vitesse, Think Deeper pour la profondeur. Les modèles (5.2 à 5.5) sont gérés automatiquement par Copilot — vous n'avez pas à y penser. Défi de la semaine: essayer Think Deeper sur une tâche que vous faites normalement en Auto!</a:t>
+              <a:t>Résumé: Auto par défaut, Quick pour la vitesse, Think Deeper pour la profondeur et la conformité. Le piège à éviter: le mauvais mode fait perdre du temps ou donne des résultats peu fiables. Défi de la semaine: essayer Think Deeper sur une tâche d'analyse ou de conformité — noter la différence de qualité.</a:t>
             </a:r>
           </a:p>
         </p:txBody>
@@ -4062,7 +3991,7 @@
               </a:defRPr>
             </a:pPr>
             <a:r>
-              <a:t>Auto · Quick Response · Think Deeper · GPT-5.2 à 5.5 • Pour IT et non-IT • Institution financière</a:t>
+              <a:t>Auto · Quick Response · Think Deeper · Pour IT et non-IT · Institution financière</a:t>
             </a:r>
           </a:p>
         </p:txBody>
@@ -4232,7 +4161,7 @@
               </a:defRPr>
             </a:pPr>
             <a:r>
-              <a:t>Le sélecteur en haut de votre écran Copilot — un outil, trois façons de penser</a:t>
+              <a:t>Le sélecteur en haut de votre écran — un outil, trois façons de penser</a:t>
             </a:r>
           </a:p>
         </p:txBody>
@@ -4331,7 +4260,7 @@
               </a:defRPr>
             </a:pPr>
             <a:r>
-              <a:t>• Quick Response → Réponse instantanée, idéal pour tâches simples</a:t>
+              <a:t>• Quick Response → Réponse en quelques secondes, idéal pour tâches simples</a:t>
             </a:r>
           </a:p>
           <a:p>
@@ -4347,7 +4276,7 @@
               </a:defRPr>
             </a:pPr>
             <a:r>
-              <a:t>• Think Deeper → Raisonnement approfondi, pour problèmes complexes</a:t>
+              <a:t>• Think Deeper → Raisonnement approfondi, pour problèmes complexes (30–90 s)</a:t>
             </a:r>
           </a:p>
         </p:txBody>
@@ -4492,7 +4421,7 @@
               </a:defRPr>
             </a:pPr>
             <a:r>
-              <a:t>Utilisé 80% du temps</a:t>
+              <a:t>Le choix par défaut</a:t>
             </a:r>
           </a:p>
           <a:p>
@@ -4521,7 +4450,7 @@
               </a:defRPr>
             </a:pPr>
             <a:r>
-              <a:t>Délègue au bon modèle</a:t>
+              <a:t>Copilot délègue au bon</a:t>
             </a:r>
           </a:p>
           <a:p>
@@ -4537,7 +4466,7 @@
               </a:defRPr>
             </a:pPr>
             <a:r>
-              <a:t>selon la complexité</a:t>
+              <a:t>modèle selon la</a:t>
             </a:r>
           </a:p>
           <a:p>
@@ -4553,7 +4482,7 @@
               </a:defRPr>
             </a:pPr>
             <a:r>
-              <a:t>de votre demande</a:t>
+              <a:t>complexité de votre</a:t>
             </a:r>
           </a:p>
           <a:p>
@@ -4568,6 +4497,9 @@
                 <a:latin typeface="Calibri"/>
               </a:defRPr>
             </a:pPr>
+            <a:r>
+              <a:t>demande</a:t>
+            </a:r>
           </a:p>
           <a:p>
             <a:pPr>
@@ -4581,9 +4513,6 @@
                 <a:latin typeface="Calibri"/>
               </a:defRPr>
             </a:pPr>
-            <a:r>
-              <a:t>Meilleur choix</a:t>
-            </a:r>
           </a:p>
           <a:p>
             <a:pPr>
@@ -4598,7 +4527,39 @@
               </a:defRPr>
             </a:pPr>
             <a:r>
-              <a:t>par défaut</a:t>
+              <a:t>Meilleur choix</a:t>
+            </a:r>
+          </a:p>
+          <a:p>
+            <a:pPr>
+              <a:spcAft>
+                <a:spcPts val="400"/>
+              </a:spcAft>
+              <a:defRPr sz="1300">
+                <a:solidFill>
+                  <a:srgbClr val="2B2B2B"/>
+                </a:solidFill>
+                <a:latin typeface="Calibri"/>
+              </a:defRPr>
+            </a:pPr>
+            <a:r>
+              <a:t>dans la grande</a:t>
+            </a:r>
+          </a:p>
+          <a:p>
+            <a:pPr>
+              <a:spcAft>
+                <a:spcPts val="400"/>
+              </a:spcAft>
+              <a:defRPr sz="1300">
+                <a:solidFill>
+                  <a:srgbClr val="2B2B2B"/>
+                </a:solidFill>
+                <a:latin typeface="Calibri"/>
+              </a:defRPr>
+            </a:pPr>
+            <a:r>
+              <a:t>majorité des cas</a:t>
             </a:r>
           </a:p>
         </p:txBody>
@@ -4743,7 +4704,7 @@
               </a:defRPr>
             </a:pPr>
             <a:r>
-              <a:t>Réponse en 2-5 secondes</a:t>
+              <a:t>Réponse en quelques</a:t>
             </a:r>
           </a:p>
           <a:p>
@@ -4758,6 +4719,9 @@
                 <a:latin typeface="Calibri"/>
               </a:defRPr>
             </a:pPr>
+            <a:r>
+              <a:t>secondes</a:t>
+            </a:r>
           </a:p>
           <a:p>
             <a:pPr>
@@ -4771,9 +4735,6 @@
                 <a:latin typeface="Calibri"/>
               </a:defRPr>
             </a:pPr>
-            <a:r>
-              <a:t>Utilise GPT-5.5 Quick</a:t>
-            </a:r>
           </a:p>
           <a:p>
             <a:pPr>
@@ -4788,7 +4749,7 @@
               </a:defRPr>
             </a:pPr>
             <a:r>
-              <a:t>ou GPT-5.3 Instant</a:t>
+              <a:t>Idéal pour:</a:t>
             </a:r>
           </a:p>
           <a:p>
@@ -4803,6 +4764,9 @@
                 <a:latin typeface="Calibri"/>
               </a:defRPr>
             </a:pPr>
+            <a:r>
+              <a:t>courriels, résumés,</a:t>
+            </a:r>
           </a:p>
           <a:p>
             <a:pPr>
@@ -4817,7 +4781,7 @@
               </a:defRPr>
             </a:pPr>
             <a:r>
-              <a:t>Idéal pour:</a:t>
+              <a:t>questions rapides,</a:t>
             </a:r>
           </a:p>
           <a:p>
@@ -4833,7 +4797,7 @@
               </a:defRPr>
             </a:pPr>
             <a:r>
-              <a:t>courriels, résumés,</a:t>
+              <a:t>reformulations</a:t>
             </a:r>
           </a:p>
           <a:p>
@@ -4848,8 +4812,21 @@
                 <a:latin typeface="Calibri"/>
               </a:defRPr>
             </a:pPr>
-            <a:r>
-              <a:t>questions rapides</a:t>
+          </a:p>
+          <a:p>
+            <a:pPr>
+              <a:spcAft>
+                <a:spcPts val="400"/>
+              </a:spcAft>
+              <a:defRPr sz="1300">
+                <a:solidFill>
+                  <a:srgbClr val="2B2B2B"/>
+                </a:solidFill>
+                <a:latin typeface="Calibri"/>
+              </a:defRPr>
+            </a:pPr>
+            <a:r>
+              <a:t>Vitesse avant tout</a:t>
             </a:r>
           </a:p>
         </p:txBody>
@@ -4994,7 +4971,7 @@
               </a:defRPr>
             </a:pPr>
             <a:r>
-              <a:t>Réponse en 15-60 secondes</a:t>
+              <a:t>Réponse en 30–90 s</a:t>
             </a:r>
           </a:p>
           <a:p>
@@ -5023,7 +5000,7 @@
               </a:defRPr>
             </a:pPr>
             <a:r>
-              <a:t>Utilise GPT-5.5 Think</a:t>
+              <a:t>Idéal pour:</a:t>
             </a:r>
           </a:p>
           <a:p>
@@ -5039,7 +5016,7 @@
               </a:defRPr>
             </a:pPr>
             <a:r>
-              <a:t>Deeper ou GPT-5.4</a:t>
+              <a:t>analyse de risques,</a:t>
             </a:r>
           </a:p>
           <a:p>
@@ -5054,6 +5031,9 @@
                 <a:latin typeface="Calibri"/>
               </a:defRPr>
             </a:pPr>
+            <a:r>
+              <a:t>conformité, code,</a:t>
+            </a:r>
           </a:p>
           <a:p>
             <a:pPr>
@@ -5068,7 +5048,7 @@
               </a:defRPr>
             </a:pPr>
             <a:r>
-              <a:t>Idéal pour:</a:t>
+              <a:t>décisions complexes</a:t>
             </a:r>
           </a:p>
           <a:p>
@@ -5083,9 +5063,6 @@
                 <a:latin typeface="Calibri"/>
               </a:defRPr>
             </a:pPr>
-            <a:r>
-              <a:t>analyse, code,</a:t>
-            </a:r>
           </a:p>
           <a:p>
             <a:pPr>
@@ -5100,7 +5077,7 @@
               </a:defRPr>
             </a:pPr>
             <a:r>
-              <a:t>décisions complexes</a:t>
+              <a:t>Précision avant vitesse</a:t>
             </a:r>
           </a:p>
         </p:txBody>
@@ -5278,7 +5255,7 @@
               </a:defRPr>
             </a:pPr>
             <a:r>
-              <a:t>La gamme de modèles — GPT-5.x</a:t>
+              <a:t>Le bon mode pour le bon moment</a:t>
             </a:r>
           </a:p>
         </p:txBody>
@@ -5314,7 +5291,7 @@
               </a:defRPr>
             </a:pPr>
             <a:r>
-              <a:t>Chaque version est plus puissante — mais pas toujours nécessaire</a:t>
+              <a:t>Exemples concrets en institution financière</a:t>
             </a:r>
           </a:p>
         </p:txBody>
@@ -5397,7 +5374,7 @@
               </a:defRPr>
             </a:pPr>
             <a:r>
-              <a:t>• GPT-5.5 Quick et 5.5 Think Deeper: les plus récents (avril 2026)</a:t>
+              <a:t>• Quick Response: tâches simples et rapides — courriels, résumés, recherches</a:t>
             </a:r>
           </a:p>
           <a:p>
@@ -5413,7 +5390,7 @@
               </a:defRPr>
             </a:pPr>
             <a:r>
-              <a:t>• GPT-5.4 Thinking: raisonnement, conservateur, fiable</a:t>
+              <a:t>• Think Deeper: analyse, conformité, code complexe — la précision vaut l'attente</a:t>
             </a:r>
           </a:p>
           <a:p>
@@ -5429,23 +5406,7 @@
               </a:defRPr>
             </a:pPr>
             <a:r>
-              <a:t>• GPT-5.3 Instant: rapide, bon équilibre vitesse/qualité</a:t>
-            </a:r>
-          </a:p>
-          <a:p>
-            <a:pPr>
-              <a:spcAft>
-                <a:spcPts val="400"/>
-              </a:spcAft>
-              <a:defRPr sz="1400">
-                <a:solidFill>
-                  <a:srgbClr val="2B2B2B"/>
-                </a:solidFill>
-                <a:latin typeface="Calibri"/>
-              </a:defRPr>
-            </a:pPr>
-            <a:r>
-              <a:t>• GPT-5.2: modèle hérité, toujours disponible si nécessaire</a:t>
+              <a:t>• Auto: laissez Copilot décider — il choisit bien dans la grande majorité des cas</a:t>
             </a:r>
           </a:p>
         </p:txBody>
@@ -5590,7 +5551,7 @@
               </a:defRPr>
             </a:pPr>
             <a:r>
-              <a:t>GPT-5.5 Quick</a:t>
+              <a:t>Répondre à un courriel</a:t>
             </a:r>
           </a:p>
           <a:p>
@@ -5606,7 +5567,7 @@
               </a:defRPr>
             </a:pPr>
             <a:r>
-              <a:t>(dernier cri)</a:t>
+              <a:t>Résumer un fil Teams</a:t>
             </a:r>
           </a:p>
           <a:p>
@@ -5621,6 +5582,9 @@
                 <a:latin typeface="Calibri"/>
               </a:defRPr>
             </a:pPr>
+            <a:r>
+              <a:t>Rédiger un document</a:t>
+            </a:r>
           </a:p>
           <a:p>
             <a:pPr>
@@ -5635,7 +5599,7 @@
               </a:defRPr>
             </a:pPr>
             <a:r>
-              <a:t>GPT-5.3 Instant</a:t>
+              <a:t>Chercher une information</a:t>
             </a:r>
           </a:p>
           <a:p>
@@ -5650,9 +5614,6 @@
                 <a:latin typeface="Calibri"/>
               </a:defRPr>
             </a:pPr>
-            <a:r>
-              <a:t>(équilibré)</a:t>
-            </a:r>
           </a:p>
           <a:p>
             <a:pPr>
@@ -5666,6 +5627,9 @@
                 <a:latin typeface="Calibri"/>
               </a:defRPr>
             </a:pPr>
+            <a:r>
+              <a:t>Quand vous voulez</a:t>
+            </a:r>
           </a:p>
           <a:p>
             <a:pPr>
@@ -5680,23 +5644,7 @@
               </a:defRPr>
             </a:pPr>
             <a:r>
-              <a:t>→ Secondes</a:t>
-            </a:r>
-          </a:p>
-          <a:p>
-            <a:pPr>
-              <a:spcAft>
-                <a:spcPts val="400"/>
-              </a:spcAft>
-              <a:defRPr sz="1300">
-                <a:solidFill>
-                  <a:srgbClr val="2B2B2B"/>
-                </a:solidFill>
-                <a:latin typeface="Calibri"/>
-              </a:defRPr>
-            </a:pPr>
-            <a:r>
-              <a:t>Tâches quotidiennes</a:t>
+              <a:t>une réponse vite</a:t>
             </a:r>
           </a:p>
         </p:txBody>
@@ -5841,7 +5789,7 @@
               </a:defRPr>
             </a:pPr>
             <a:r>
-              <a:t>GPT-5.5 Think Deeper</a:t>
+              <a:t>Analyser des données</a:t>
             </a:r>
           </a:p>
           <a:p>
@@ -5857,7 +5805,7 @@
               </a:defRPr>
             </a:pPr>
             <a:r>
-              <a:t>(dernier cri)</a:t>
+              <a:t>Écrire du code complexe</a:t>
             </a:r>
           </a:p>
           <a:p>
@@ -5872,6 +5820,9 @@
                 <a:latin typeface="Calibri"/>
               </a:defRPr>
             </a:pPr>
+            <a:r>
+              <a:t>Évaluer la conformité</a:t>
+            </a:r>
           </a:p>
           <a:p>
             <a:pPr>
@@ -5886,7 +5837,7 @@
               </a:defRPr>
             </a:pPr>
             <a:r>
-              <a:t>GPT-5.4 Thinking</a:t>
+              <a:t>Analyse de risques</a:t>
             </a:r>
           </a:p>
           <a:p>
@@ -5901,9 +5852,6 @@
                 <a:latin typeface="Calibri"/>
               </a:defRPr>
             </a:pPr>
-            <a:r>
-              <a:t>(fiable, conservateur)</a:t>
-            </a:r>
           </a:p>
           <a:p>
             <a:pPr>
@@ -5917,6 +5865,9 @@
                 <a:latin typeface="Calibri"/>
               </a:defRPr>
             </a:pPr>
+            <a:r>
+              <a:t>Quand la précision</a:t>
+            </a:r>
           </a:p>
           <a:p>
             <a:pPr>
@@ -5931,23 +5882,7 @@
               </a:defRPr>
             </a:pPr>
             <a:r>
-              <a:t>→ Minutes</a:t>
-            </a:r>
-          </a:p>
-          <a:p>
-            <a:pPr>
-              <a:spcAft>
-                <a:spcPts val="400"/>
-              </a:spcAft>
-              <a:defRPr sz="1300">
-                <a:solidFill>
-                  <a:srgbClr val="2B2B2B"/>
-                </a:solidFill>
-                <a:latin typeface="Calibri"/>
-              </a:defRPr>
-            </a:pPr>
-            <a:r>
-              <a:t>Analyse, code, risque</a:t>
+              <a:t>prime sur la vitesse</a:t>
             </a:r>
           </a:p>
         </p:txBody>
@@ -6000,7 +5935,7 @@
       </p:sp>
       <p:pic>
         <p:nvPicPr>
-          <p:cNvPr id="15" name="Picture 14" descr="history_EF4444_30.png"/>
+          <p:cNvPr id="15" name="Picture 14" descr="triangle-alert_EF4444_30.png"/>
           <p:cNvPicPr>
             <a:picLocks noChangeAspect="1"/>
           </p:cNvPicPr>
@@ -6053,7 +5988,7 @@
               </a:defRPr>
             </a:pPr>
             <a:r>
-              <a:t>Héritage</a:t>
+              <a:t>Attention: mauvais mode</a:t>
             </a:r>
           </a:p>
         </p:txBody>
@@ -6092,7 +6027,7 @@
               </a:defRPr>
             </a:pPr>
             <a:r>
-              <a:t>GPT-5.2</a:t>
+              <a:t>Think Deeper pour un</a:t>
             </a:r>
           </a:p>
           <a:p>
@@ -6107,6 +6042,9 @@
                 <a:latin typeface="Calibri"/>
               </a:defRPr>
             </a:pPr>
+            <a:r>
+              <a:t>courriel simple = 60 s</a:t>
+            </a:r>
           </a:p>
           <a:p>
             <a:pPr>
@@ -6121,7 +6059,7 @@
               </a:defRPr>
             </a:pPr>
             <a:r>
-              <a:t>Modèle précédent</a:t>
+              <a:t>d'attente inutile</a:t>
             </a:r>
           </a:p>
           <a:p>
@@ -6136,9 +6074,6 @@
                 <a:latin typeface="Calibri"/>
               </a:defRPr>
             </a:pPr>
-            <a:r>
-              <a:t>encore disponible</a:t>
-            </a:r>
           </a:p>
           <a:p>
             <a:pPr>
@@ -6152,6 +6087,9 @@
                 <a:latin typeface="Calibri"/>
               </a:defRPr>
             </a:pPr>
+            <a:r>
+              <a:t>Quick Response pour</a:t>
+            </a:r>
           </a:p>
           <a:p>
             <a:pPr>
@@ -6166,7 +6104,7 @@
               </a:defRPr>
             </a:pPr>
             <a:r>
-              <a:t>Compatibilité</a:t>
+              <a:t>une analyse de risques</a:t>
             </a:r>
           </a:p>
           <a:p>
@@ -6182,7 +6120,7 @@
               </a:defRPr>
             </a:pPr>
             <a:r>
-              <a:t>pour tâches</a:t>
+              <a:t>= résultat peu fiable</a:t>
             </a:r>
           </a:p>
           <a:p>
@@ -6197,8 +6135,21 @@
                 <a:latin typeface="Calibri"/>
               </a:defRPr>
             </a:pPr>
-            <a:r>
-              <a:t>existantes</a:t>
+          </a:p>
+          <a:p>
+            <a:pPr>
+              <a:spcAft>
+                <a:spcPts val="400"/>
+              </a:spcAft>
+              <a:defRPr sz="1300">
+                <a:solidFill>
+                  <a:srgbClr val="2B2B2B"/>
+                </a:solidFill>
+                <a:latin typeface="Calibri"/>
+              </a:defRPr>
+            </a:pPr>
+            <a:r>
+              <a:t>Auto évite ces pièges</a:t>
             </a:r>
           </a:p>
         </p:txBody>
@@ -6376,56 +6327,20 @@
               </a:defRPr>
             </a:pPr>
             <a:r>
-              <a:t>Scénarios en institution financière</a:t>
-            </a:r>
-          </a:p>
-        </p:txBody>
-      </p:sp>
-      <p:sp>
-        <p:nvSpPr>
-          <p:cNvPr id="3" name="TextBox 2"/>
-          <p:cNvSpPr txBox="1"/>
-          <p:nvPr/>
-        </p:nvSpPr>
-        <p:spPr>
-          <a:xfrm>
-            <a:off x="457200" y="1005840"/>
-            <a:ext cx="10972800" cy="411480"/>
-          </a:xfrm>
-          <a:prstGeom prst="rect">
-            <a:avLst/>
-          </a:prstGeom>
-          <a:noFill/>
-        </p:spPr>
-        <p:txBody>
-          <a:bodyPr wrap="square" lIns="45720" rIns="45720" tIns="18288" bIns="18288">
-            <a:spAutoFit/>
-          </a:bodyPr>
-          <a:lstStyle/>
-          <a:p>
-            <a:pPr algn="l">
-              <a:defRPr sz="1500" b="0">
-                <a:solidFill>
-                  <a:srgbClr val="6B6B6B"/>
-                </a:solidFill>
-                <a:latin typeface="Calibri"/>
-              </a:defRPr>
-            </a:pPr>
-            <a:r>
-              <a:t>Quand utiliser quel mode — exemples concrets</a:t>
-            </a:r>
-          </a:p>
-        </p:txBody>
-      </p:sp>
-      <p:sp>
-        <p:nvSpPr>
-          <p:cNvPr id="4" name="Rectangle 3"/>
+              <a:t>Trucs et astuces</a:t>
+            </a:r>
+          </a:p>
+        </p:txBody>
+      </p:sp>
+      <p:sp>
+        <p:nvSpPr>
+          <p:cNvPr id="3" name="Rectangle 2"/>
           <p:cNvSpPr/>
           <p:nvPr/>
         </p:nvSpPr>
         <p:spPr>
           <a:xfrm>
-            <a:off x="457200" y="1508760"/>
+            <a:off x="457200" y="1234440"/>
             <a:ext cx="11274552" cy="18288"/>
           </a:xfrm>
           <a:prstGeom prst="rect">
@@ -6463,85 +6378,14 @@
       </p:sp>
       <p:sp>
         <p:nvSpPr>
-          <p:cNvPr id="5" name="TextBox 4"/>
-          <p:cNvSpPr txBox="1"/>
-          <p:nvPr/>
-        </p:nvSpPr>
-        <p:spPr>
-          <a:xfrm>
-            <a:off x="457200" y="1737360"/>
-            <a:ext cx="10972800" cy="1188720"/>
-          </a:xfrm>
-          <a:prstGeom prst="rect">
-            <a:avLst/>
-          </a:prstGeom>
-          <a:noFill/>
-        </p:spPr>
-        <p:txBody>
-          <a:bodyPr wrap="square">
-            <a:spAutoFit/>
-          </a:bodyPr>
-          <a:lstStyle/>
-          <a:p>
-            <a:pPr>
-              <a:spcAft>
-                <a:spcPts val="400"/>
-              </a:spcAft>
-              <a:defRPr sz="1400">
-                <a:solidFill>
-                  <a:srgbClr val="2B2B2B"/>
-                </a:solidFill>
-                <a:latin typeface="Calibri"/>
-              </a:defRPr>
-            </a:pPr>
-            <a:r>
-              <a:t>• Auto: 80% du temps — laissez Copilot décider</a:t>
-            </a:r>
-          </a:p>
-          <a:p>
-            <a:pPr>
-              <a:spcAft>
-                <a:spcPts val="400"/>
-              </a:spcAft>
-              <a:defRPr sz="1400">
-                <a:solidFill>
-                  <a:srgbClr val="2B2B2B"/>
-                </a:solidFill>
-                <a:latin typeface="Calibri"/>
-              </a:defRPr>
-            </a:pPr>
-            <a:r>
-              <a:t>• Quick Response: tâches simples, courriels, résumés rapides</a:t>
-            </a:r>
-          </a:p>
-          <a:p>
-            <a:pPr>
-              <a:spcAft>
-                <a:spcPts val="400"/>
-              </a:spcAft>
-              <a:defRPr sz="1400">
-                <a:solidFill>
-                  <a:srgbClr val="2B2B2B"/>
-                </a:solidFill>
-                <a:latin typeface="Calibri"/>
-              </a:defRPr>
-            </a:pPr>
-            <a:r>
-              <a:t>• Think Deeper: analyse de risques, code complexe, conformité</a:t>
-            </a:r>
-          </a:p>
-        </p:txBody>
-      </p:sp>
-      <p:sp>
-        <p:nvSpPr>
-          <p:cNvPr id="6" name="Rectangle 5"/>
+          <p:cNvPr id="4" name="Rectangle 3"/>
           <p:cNvSpPr/>
           <p:nvPr/>
         </p:nvSpPr>
         <p:spPr>
           <a:xfrm>
-            <a:off x="457200" y="2926080"/>
-            <a:ext cx="3383280" cy="3291840"/>
+            <a:off x="457200" y="1463040"/>
+            <a:ext cx="3383280" cy="4754880"/>
           </a:xfrm>
           <a:prstGeom prst="rect">
             <a:avLst/>
@@ -6580,7 +6424,7 @@
       </p:sp>
       <p:pic>
         <p:nvPicPr>
-          <p:cNvPr id="7" name="Picture 6" descr="zap_00874E_30.png"/>
+          <p:cNvPr id="5" name="Picture 4" descr="eye_00874E_30.png"/>
           <p:cNvPicPr>
             <a:picLocks noChangeAspect="1"/>
           </p:cNvPicPr>
@@ -6594,7 +6438,7 @@
         </p:blipFill>
         <p:spPr>
           <a:xfrm>
-            <a:off x="713232" y="3090672"/>
+            <a:off x="713232" y="1627632"/>
             <a:ext cx="292608" cy="292608"/>
           </a:xfrm>
           <a:prstGeom prst="rect">
@@ -6604,13 +6448,13 @@
       </p:pic>
       <p:sp>
         <p:nvSpPr>
-          <p:cNvPr id="8" name="TextBox 7"/>
+          <p:cNvPr id="6" name="TextBox 5"/>
           <p:cNvSpPr txBox="1"/>
           <p:nvPr/>
         </p:nvSpPr>
         <p:spPr>
           <a:xfrm>
-            <a:off x="1115568" y="3108960"/>
+            <a:off x="1115568" y="1645920"/>
             <a:ext cx="2542032" cy="457200"/>
           </a:xfrm>
           <a:prstGeom prst="rect">
@@ -6633,21 +6477,21 @@
               </a:defRPr>
             </a:pPr>
             <a:r>
-              <a:t>Quick Response</a:t>
-            </a:r>
-          </a:p>
-        </p:txBody>
-      </p:sp>
-      <p:sp>
-        <p:nvSpPr>
-          <p:cNvPr id="9" name="TextBox 8"/>
+              <a:t>Astuce 1 — Vérifiez le mode</a:t>
+            </a:r>
+          </a:p>
+        </p:txBody>
+      </p:sp>
+      <p:sp>
+        <p:nvSpPr>
+          <p:cNvPr id="7" name="TextBox 6"/>
           <p:cNvSpPr txBox="1"/>
           <p:nvPr/>
         </p:nvSpPr>
         <p:spPr>
           <a:xfrm>
-            <a:off x="731520" y="3703320"/>
-            <a:ext cx="2834640" cy="2331720"/>
+            <a:off x="731520" y="2240280"/>
+            <a:ext cx="2834640" cy="3794760"/>
           </a:xfrm>
           <a:prstGeom prst="rect">
             <a:avLst/>
@@ -6672,7 +6516,7 @@
               </a:defRPr>
             </a:pPr>
             <a:r>
-              <a:t>Répondre à un courriel</a:t>
+              <a:t>Le mode reste actif</a:t>
             </a:r>
           </a:p>
           <a:p>
@@ -6688,7 +6532,7 @@
               </a:defRPr>
             </a:pPr>
             <a:r>
-              <a:t>Résumer un fil Teams</a:t>
+              <a:t>d'une session à l'autre.</a:t>
             </a:r>
           </a:p>
           <a:p>
@@ -6703,9 +6547,6 @@
                 <a:latin typeface="Calibri"/>
               </a:defRPr>
             </a:pPr>
-            <a:r>
-              <a:t>Rédiger un document</a:t>
-            </a:r>
           </a:p>
           <a:p>
             <a:pPr>
@@ -6720,7 +6561,7 @@
               </a:defRPr>
             </a:pPr>
             <a:r>
-              <a:t>Chercher une information</a:t>
+              <a:t>Avant de commencer,</a:t>
             </a:r>
           </a:p>
           <a:p>
@@ -6736,7 +6577,7 @@
               </a:defRPr>
             </a:pPr>
             <a:r>
-              <a:t>Quand tu veux une</a:t>
+              <a:t>regardez quel mode</a:t>
             </a:r>
           </a:p>
           <a:p>
@@ -6752,21 +6593,37 @@
               </a:defRPr>
             </a:pPr>
             <a:r>
-              <a:t>réponse vite</a:t>
-            </a:r>
-          </a:p>
-        </p:txBody>
-      </p:sp>
-      <p:sp>
-        <p:nvSpPr>
-          <p:cNvPr id="10" name="Rectangle 9"/>
+              <a:t>est sélectionné en haut</a:t>
+            </a:r>
+          </a:p>
+          <a:p>
+            <a:pPr>
+              <a:spcAft>
+                <a:spcPts val="400"/>
+              </a:spcAft>
+              <a:defRPr sz="1300">
+                <a:solidFill>
+                  <a:srgbClr val="2B2B2B"/>
+                </a:solidFill>
+                <a:latin typeface="Calibri"/>
+              </a:defRPr>
+            </a:pPr>
+            <a:r>
+              <a:t>de votre écran Copilot.</a:t>
+            </a:r>
+          </a:p>
+        </p:txBody>
+      </p:sp>
+      <p:sp>
+        <p:nvSpPr>
+          <p:cNvPr id="8" name="Rectangle 7"/>
           <p:cNvSpPr/>
           <p:nvPr/>
         </p:nvSpPr>
         <p:spPr>
           <a:xfrm>
-            <a:off x="4114800" y="2926080"/>
-            <a:ext cx="3383280" cy="3291840"/>
+            <a:off x="4114800" y="1463040"/>
+            <a:ext cx="3383280" cy="4754880"/>
           </a:xfrm>
           <a:prstGeom prst="rect">
             <a:avLst/>
@@ -6805,7 +6662,7 @@
       </p:sp>
       <p:pic>
         <p:nvPicPr>
-          <p:cNvPr id="11" name="Picture 10" descr="brain_F59E0B_30.png"/>
+          <p:cNvPr id="9" name="Picture 8" descr="shield-check_00874E_30.png"/>
           <p:cNvPicPr>
             <a:picLocks noChangeAspect="1"/>
           </p:cNvPicPr>
@@ -6819,7 +6676,7 @@
         </p:blipFill>
         <p:spPr>
           <a:xfrm>
-            <a:off x="4370832" y="3090672"/>
+            <a:off x="4370832" y="1627632"/>
             <a:ext cx="292608" cy="292608"/>
           </a:xfrm>
           <a:prstGeom prst="rect">
@@ -6829,13 +6686,13 @@
       </p:pic>
       <p:sp>
         <p:nvSpPr>
-          <p:cNvPr id="12" name="TextBox 11"/>
+          <p:cNvPr id="10" name="TextBox 9"/>
           <p:cNvSpPr txBox="1"/>
           <p:nvPr/>
         </p:nvSpPr>
         <p:spPr>
           <a:xfrm>
-            <a:off x="4773168" y="3108960"/>
+            <a:off x="4773168" y="1645920"/>
             <a:ext cx="2542031" cy="457200"/>
           </a:xfrm>
           <a:prstGeom prst="rect">
@@ -6852,27 +6709,27 @@
             <a:pPr algn="l">
               <a:defRPr sz="1700" b="1">
                 <a:solidFill>
-                  <a:srgbClr val="F59E0B"/>
-                </a:solidFill>
-                <a:latin typeface="Calibri"/>
-              </a:defRPr>
-            </a:pPr>
-            <a:r>
-              <a:t>Think Deeper</a:t>
-            </a:r>
-          </a:p>
-        </p:txBody>
-      </p:sp>
-      <p:sp>
-        <p:nvSpPr>
-          <p:cNvPr id="13" name="TextBox 12"/>
+                  <a:srgbClr val="00874E"/>
+                </a:solidFill>
+                <a:latin typeface="Calibri"/>
+              </a:defRPr>
+            </a:pPr>
+            <a:r>
+              <a:t>Astuce 2 — Conformité</a:t>
+            </a:r>
+          </a:p>
+        </p:txBody>
+      </p:sp>
+      <p:sp>
+        <p:nvSpPr>
+          <p:cNvPr id="11" name="TextBox 10"/>
           <p:cNvSpPr txBox="1"/>
           <p:nvPr/>
         </p:nvSpPr>
         <p:spPr>
           <a:xfrm>
-            <a:off x="4389120" y="3703320"/>
-            <a:ext cx="2834640" cy="2331720"/>
+            <a:off x="4389120" y="2240280"/>
+            <a:ext cx="2834640" cy="3794760"/>
           </a:xfrm>
           <a:prstGeom prst="rect">
             <a:avLst/>
@@ -6897,7 +6754,7 @@
               </a:defRPr>
             </a:pPr>
             <a:r>
-              <a:t>Analyser des données</a:t>
+              <a:t>En institution financière,</a:t>
             </a:r>
           </a:p>
           <a:p>
@@ -6913,7 +6770,7 @@
               </a:defRPr>
             </a:pPr>
             <a:r>
-              <a:t>Écrire du code complexe</a:t>
+              <a:t>utilisez Think Deeper</a:t>
             </a:r>
           </a:p>
           <a:p>
@@ -6929,7 +6786,7 @@
               </a:defRPr>
             </a:pPr>
             <a:r>
-              <a:t>Évaluer la conformité</a:t>
+              <a:t>pour toute analyse</a:t>
             </a:r>
           </a:p>
           <a:p>
@@ -6945,7 +6802,7 @@
               </a:defRPr>
             </a:pPr>
             <a:r>
-              <a:t>Analyse de risques</a:t>
+              <a:t>impliquant conformité</a:t>
             </a:r>
           </a:p>
           <a:p>
@@ -6961,7 +6818,7 @@
               </a:defRPr>
             </a:pPr>
             <a:r>
-              <a:t>Quand la précision</a:t>
+              <a:t>ou données sensibles.</a:t>
             </a:r>
           </a:p>
           <a:p>
@@ -6976,22 +6833,35 @@
                 <a:latin typeface="Calibri"/>
               </a:defRPr>
             </a:pPr>
-            <a:r>
-              <a:t>prime sur la vitesse</a:t>
-            </a:r>
-          </a:p>
-        </p:txBody>
-      </p:sp>
-      <p:sp>
-        <p:nvSpPr>
-          <p:cNvPr id="14" name="Rectangle 13"/>
+          </a:p>
+          <a:p>
+            <a:pPr>
+              <a:spcAft>
+                <a:spcPts val="400"/>
+              </a:spcAft>
+              <a:defRPr sz="1300">
+                <a:solidFill>
+                  <a:srgbClr val="2B2B2B"/>
+                </a:solidFill>
+                <a:latin typeface="Calibri"/>
+              </a:defRPr>
+            </a:pPr>
+            <a:r>
+              <a:t>La rigueur vaut l'attente.</a:t>
+            </a:r>
+          </a:p>
+        </p:txBody>
+      </p:sp>
+      <p:sp>
+        <p:nvSpPr>
+          <p:cNvPr id="12" name="Rectangle 11"/>
           <p:cNvSpPr/>
           <p:nvPr/>
         </p:nvSpPr>
         <p:spPr>
           <a:xfrm>
-            <a:off x="7772400" y="2926080"/>
-            <a:ext cx="3383280" cy="3291840"/>
+            <a:off x="7772400" y="1463040"/>
+            <a:ext cx="3383280" cy="4754880"/>
           </a:xfrm>
           <a:prstGeom prst="rect">
             <a:avLst/>
@@ -7030,7 +6900,7 @@
       </p:sp>
       <p:pic>
         <p:nvPicPr>
-          <p:cNvPr id="15" name="Picture 14" descr="circle-dot_00874E_30.png"/>
+          <p:cNvPr id="13" name="Picture 12" descr="lightbulb_F59E0B_30.png"/>
           <p:cNvPicPr>
             <a:picLocks noChangeAspect="1"/>
           </p:cNvPicPr>
@@ -7044,7 +6914,7 @@
         </p:blipFill>
         <p:spPr>
           <a:xfrm>
-            <a:off x="8028431" y="3090672"/>
+            <a:off x="8028431" y="1627632"/>
             <a:ext cx="292608" cy="292608"/>
           </a:xfrm>
           <a:prstGeom prst="rect">
@@ -7054,13 +6924,13 @@
       </p:pic>
       <p:sp>
         <p:nvSpPr>
-          <p:cNvPr id="16" name="TextBox 15"/>
+          <p:cNvPr id="14" name="TextBox 13"/>
           <p:cNvSpPr txBox="1"/>
           <p:nvPr/>
         </p:nvSpPr>
         <p:spPr>
           <a:xfrm>
-            <a:off x="8430767" y="3108960"/>
+            <a:off x="8430767" y="1645920"/>
             <a:ext cx="2542032" cy="457200"/>
           </a:xfrm>
           <a:prstGeom prst="rect">
@@ -7077,27 +6947,27 @@
             <a:pPr algn="l">
               <a:defRPr sz="1700" b="1">
                 <a:solidFill>
-                  <a:srgbClr val="00874E"/>
-                </a:solidFill>
-                <a:latin typeface="Calibri"/>
-              </a:defRPr>
-            </a:pPr>
-            <a:r>
-              <a:t>Auto (le bon choix)</a:t>
-            </a:r>
-          </a:p>
-        </p:txBody>
-      </p:sp>
-      <p:sp>
-        <p:nvSpPr>
-          <p:cNvPr id="17" name="TextBox 16"/>
+                  <a:srgbClr val="F59E0B"/>
+                </a:solidFill>
+                <a:latin typeface="Calibri"/>
+              </a:defRPr>
+            </a:pPr>
+            <a:r>
+              <a:t>Astuce 3 — Combo gagnant</a:t>
+            </a:r>
+          </a:p>
+        </p:txBody>
+      </p:sp>
+      <p:sp>
+        <p:nvSpPr>
+          <p:cNvPr id="15" name="TextBox 14"/>
           <p:cNvSpPr txBox="1"/>
           <p:nvPr/>
         </p:nvSpPr>
         <p:spPr>
           <a:xfrm>
-            <a:off x="8046720" y="3703320"/>
-            <a:ext cx="2834640" cy="2331720"/>
+            <a:off x="8046720" y="2240280"/>
+            <a:ext cx="2834640" cy="3794760"/>
           </a:xfrm>
           <a:prstGeom prst="rect">
             <a:avLst/>
@@ -7122,7 +6992,7 @@
               </a:defRPr>
             </a:pPr>
             <a:r>
-              <a:t>80% des cas</a:t>
+              <a:t>Think Deeper +</a:t>
             </a:r>
           </a:p>
           <a:p>
@@ -7138,7 +7008,7 @@
               </a:defRPr>
             </a:pPr>
             <a:r>
-              <a:t>Copilot choisit le bon</a:t>
+              <a:t>persona expert =</a:t>
             </a:r>
           </a:p>
           <a:p>
@@ -7154,7 +7024,7 @@
               </a:defRPr>
             </a:pPr>
             <a:r>
-              <a:t>modèle pour vous</a:t>
+              <a:t>analyse de qualité</a:t>
             </a:r>
           </a:p>
           <a:p>
@@ -7169,6 +7039,9 @@
                 <a:latin typeface="Calibri"/>
               </a:defRPr>
             </a:pPr>
+            <a:r>
+              <a:t>professionnelle</a:t>
+            </a:r>
           </a:p>
           <a:p>
             <a:pPr>
@@ -7182,9 +7055,6 @@
                 <a:latin typeface="Calibri"/>
               </a:defRPr>
             </a:pPr>
-            <a:r>
-              <a:t>Vous n'avez pas à</a:t>
-            </a:r>
           </a:p>
           <a:p>
             <a:pPr>
@@ -7199,7 +7069,7 @@
               </a:defRPr>
             </a:pPr>
             <a:r>
-              <a:t>y penser!</a:t>
+              <a:t>Ex: Think Deeper +</a:t>
             </a:r>
           </a:p>
           <a:p>
@@ -7214,28 +7084,15 @@
                 <a:latin typeface="Calibri"/>
               </a:defRPr>
             </a:pPr>
-          </a:p>
-          <a:p>
-            <a:pPr>
-              <a:spcAft>
-                <a:spcPts val="400"/>
-              </a:spcAft>
-              <a:defRPr sz="1300">
-                <a:solidFill>
-                  <a:srgbClr val="2B2B2B"/>
-                </a:solidFill>
-                <a:latin typeface="Calibri"/>
-              </a:defRPr>
-            </a:pPr>
-            <a:r>
-              <a:t>Laisser faire!</a:t>
-            </a:r>
-          </a:p>
-        </p:txBody>
-      </p:sp>
-      <p:sp>
-        <p:nvSpPr>
-          <p:cNvPr id="18" name="Rectangle 17"/>
+            <a:r>
+              <a:t>«auditeur interne»</a:t>
+            </a:r>
+          </a:p>
+        </p:txBody>
+      </p:sp>
+      <p:sp>
+        <p:nvSpPr>
+          <p:cNvPr id="16" name="Rectangle 15"/>
           <p:cNvSpPr/>
           <p:nvPr/>
         </p:nvSpPr>
@@ -7279,7 +7136,7 @@
       </p:sp>
       <p:sp>
         <p:nvSpPr>
-          <p:cNvPr id="19" name="TextBox 18"/>
+          <p:cNvPr id="17" name="TextBox 16"/>
           <p:cNvSpPr txBox="1"/>
           <p:nvPr/>
         </p:nvSpPr>
@@ -7315,7 +7172,7 @@
       </p:sp>
       <p:sp>
         <p:nvSpPr>
-          <p:cNvPr id="20" name="TextBox 19"/>
+          <p:cNvPr id="18" name="TextBox 17"/>
           <p:cNvSpPr txBox="1"/>
           <p:nvPr/>
         </p:nvSpPr>
@@ -7358,807 +7215,6 @@
 </file>
 
 <file path=ppt/slides/slide5.xml><?xml version="1.0" encoding="utf-8"?>
-<p:sld xmlns:a="http://schemas.openxmlformats.org/drawingml/2006/main" xmlns:p="http://schemas.openxmlformats.org/presentationml/2006/main" xmlns:r="http://schemas.openxmlformats.org/officeDocument/2006/relationships">
-  <p:cSld>
-    <p:bg>
-      <p:bgPr>
-        <a:solidFill>
-          <a:srgbClr val="E6F0EA"/>
-        </a:solidFill>
-        <a:effectLst/>
-      </p:bgPr>
-    </p:bg>
-    <p:spTree>
-      <p:nvGrpSpPr>
-        <p:cNvPr id="1" name=""/>
-        <p:cNvGrpSpPr/>
-        <p:nvPr/>
-      </p:nvGrpSpPr>
-      <p:grpSpPr/>
-      <p:sp>
-        <p:nvSpPr>
-          <p:cNvPr id="2" name="TextBox 1"/>
-          <p:cNvSpPr txBox="1"/>
-          <p:nvPr/>
-        </p:nvSpPr>
-        <p:spPr>
-          <a:xfrm>
-            <a:off x="457200" y="365760"/>
-            <a:ext cx="10972800" cy="731520"/>
-          </a:xfrm>
-          <a:prstGeom prst="rect">
-            <a:avLst/>
-          </a:prstGeom>
-          <a:noFill/>
-        </p:spPr>
-        <p:txBody>
-          <a:bodyPr wrap="square" lIns="45720" rIns="45720" tIns="18288" bIns="18288">
-            <a:spAutoFit/>
-          </a:bodyPr>
-          <a:lstStyle/>
-          <a:p>
-            <a:pPr algn="l">
-              <a:defRPr sz="2800" b="1">
-                <a:solidFill>
-                  <a:srgbClr val="006B3F"/>
-                </a:solidFill>
-                <a:latin typeface="Calibri"/>
-              </a:defRPr>
-            </a:pPr>
-            <a:r>
-              <a:t>Trucs et astuces</a:t>
-            </a:r>
-          </a:p>
-        </p:txBody>
-      </p:sp>
-      <p:sp>
-        <p:nvSpPr>
-          <p:cNvPr id="3" name="Rectangle 2"/>
-          <p:cNvSpPr/>
-          <p:nvPr/>
-        </p:nvSpPr>
-        <p:spPr>
-          <a:xfrm>
-            <a:off x="457200" y="1234440"/>
-            <a:ext cx="11274552" cy="18288"/>
-          </a:xfrm>
-          <a:prstGeom prst="rect">
-            <a:avLst/>
-          </a:prstGeom>
-          <a:solidFill>
-            <a:srgbClr val="00874E"/>
-          </a:solidFill>
-          <a:ln>
-            <a:noFill/>
-          </a:ln>
-          <a:effectLst/>
-        </p:spPr>
-        <p:style>
-          <a:lnRef idx="1">
-            <a:schemeClr val="accent1"/>
-          </a:lnRef>
-          <a:fillRef idx="3">
-            <a:schemeClr val="accent1"/>
-          </a:fillRef>
-          <a:effectRef idx="2">
-            <a:schemeClr val="accent1"/>
-          </a:effectRef>
-          <a:fontRef idx="minor">
-            <a:schemeClr val="lt1"/>
-          </a:fontRef>
-        </p:style>
-        <p:txBody>
-          <a:bodyPr rtlCol="0" anchor="ctr"/>
-          <a:lstStyle/>
-          <a:p>
-            <a:pPr algn="ctr"/>
-          </a:p>
-        </p:txBody>
-      </p:sp>
-      <p:sp>
-        <p:nvSpPr>
-          <p:cNvPr id="4" name="Rectangle 3"/>
-          <p:cNvSpPr/>
-          <p:nvPr/>
-        </p:nvSpPr>
-        <p:spPr>
-          <a:xfrm>
-            <a:off x="457200" y="1463040"/>
-            <a:ext cx="3383280" cy="4754880"/>
-          </a:xfrm>
-          <a:prstGeom prst="rect">
-            <a:avLst/>
-          </a:prstGeom>
-          <a:solidFill>
-            <a:srgbClr val="FFFFFF"/>
-          </a:solidFill>
-          <a:ln>
-            <a:solidFill>
-              <a:srgbClr val="E0E0E0"/>
-            </a:solidFill>
-          </a:ln>
-          <a:effectLst/>
-        </p:spPr>
-        <p:style>
-          <a:lnRef idx="1">
-            <a:schemeClr val="accent1"/>
-          </a:lnRef>
-          <a:fillRef idx="3">
-            <a:schemeClr val="accent1"/>
-          </a:fillRef>
-          <a:effectRef idx="2">
-            <a:schemeClr val="accent1"/>
-          </a:effectRef>
-          <a:fontRef idx="minor">
-            <a:schemeClr val="lt1"/>
-          </a:fontRef>
-        </p:style>
-        <p:txBody>
-          <a:bodyPr rtlCol="0" anchor="ctr"/>
-          <a:lstStyle/>
-          <a:p>
-            <a:pPr algn="ctr"/>
-          </a:p>
-        </p:txBody>
-      </p:sp>
-      <p:pic>
-        <p:nvPicPr>
-          <p:cNvPr id="5" name="Picture 4" descr="lightbulb_00874E_30.png"/>
-          <p:cNvPicPr>
-            <a:picLocks noChangeAspect="1"/>
-          </p:cNvPicPr>
-          <p:nvPr/>
-        </p:nvPicPr>
-        <p:blipFill>
-          <a:blip r:embed="rId3"/>
-          <a:stretch>
-            <a:fillRect/>
-          </a:stretch>
-        </p:blipFill>
-        <p:spPr>
-          <a:xfrm>
-            <a:off x="713232" y="1627632"/>
-            <a:ext cx="292608" cy="292608"/>
-          </a:xfrm>
-          <a:prstGeom prst="rect">
-            <a:avLst/>
-          </a:prstGeom>
-        </p:spPr>
-      </p:pic>
-      <p:sp>
-        <p:nvSpPr>
-          <p:cNvPr id="6" name="TextBox 5"/>
-          <p:cNvSpPr txBox="1"/>
-          <p:nvPr/>
-        </p:nvSpPr>
-        <p:spPr>
-          <a:xfrm>
-            <a:off x="1115568" y="1645920"/>
-            <a:ext cx="2542032" cy="457200"/>
-          </a:xfrm>
-          <a:prstGeom prst="rect">
-            <a:avLst/>
-          </a:prstGeom>
-          <a:noFill/>
-        </p:spPr>
-        <p:txBody>
-          <a:bodyPr wrap="square" lIns="45720" rIns="45720" tIns="18288" bIns="18288">
-            <a:spAutoFit/>
-          </a:bodyPr>
-          <a:lstStyle/>
-          <a:p>
-            <a:pPr algn="l">
-              <a:defRPr sz="1700" b="1">
-                <a:solidFill>
-                  <a:srgbClr val="00874E"/>
-                </a:solidFill>
-                <a:latin typeface="Calibri"/>
-              </a:defRPr>
-            </a:pPr>
-            <a:r>
-              <a:t>Astuce 1</a:t>
-            </a:r>
-          </a:p>
-        </p:txBody>
-      </p:sp>
-      <p:sp>
-        <p:nvSpPr>
-          <p:cNvPr id="7" name="TextBox 6"/>
-          <p:cNvSpPr txBox="1"/>
-          <p:nvPr/>
-        </p:nvSpPr>
-        <p:spPr>
-          <a:xfrm>
-            <a:off x="731520" y="2240280"/>
-            <a:ext cx="2834640" cy="3794760"/>
-          </a:xfrm>
-          <a:prstGeom prst="rect">
-            <a:avLst/>
-          </a:prstGeom>
-          <a:noFill/>
-        </p:spPr>
-        <p:txBody>
-          <a:bodyPr wrap="square">
-            <a:spAutoFit/>
-          </a:bodyPr>
-          <a:lstStyle/>
-          <a:p>
-            <a:pPr>
-              <a:spcAft>
-                <a:spcPts val="400"/>
-              </a:spcAft>
-              <a:defRPr sz="1300">
-                <a:solidFill>
-                  <a:srgbClr val="2B2B2B"/>
-                </a:solidFill>
-                <a:latin typeface="Calibri"/>
-              </a:defRPr>
-            </a:pPr>
-            <a:r>
-              <a:t>Le mode Auto est excellent</a:t>
-            </a:r>
-          </a:p>
-          <a:p>
-            <a:pPr>
-              <a:spcAft>
-                <a:spcPts val="400"/>
-              </a:spcAft>
-              <a:defRPr sz="1300">
-                <a:solidFill>
-                  <a:srgbClr val="2B2B2B"/>
-                </a:solidFill>
-                <a:latin typeface="Calibri"/>
-              </a:defRPr>
-            </a:pPr>
-            <a:r>
-              <a:t>mais si votre tâche est</a:t>
-            </a:r>
-          </a:p>
-          <a:p>
-            <a:pPr>
-              <a:spcAft>
-                <a:spcPts val="400"/>
-              </a:spcAft>
-              <a:defRPr sz="1300">
-                <a:solidFill>
-                  <a:srgbClr val="2B2B2B"/>
-                </a:solidFill>
-                <a:latin typeface="Calibri"/>
-              </a:defRPr>
-            </a:pPr>
-            <a:r>
-              <a:t>complexe, passez en</a:t>
-            </a:r>
-          </a:p>
-          <a:p>
-            <a:pPr>
-              <a:spcAft>
-                <a:spcPts val="400"/>
-              </a:spcAft>
-              <a:defRPr sz="1300">
-                <a:solidFill>
-                  <a:srgbClr val="2B2B2B"/>
-                </a:solidFill>
-                <a:latin typeface="Calibri"/>
-              </a:defRPr>
-            </a:pPr>
-            <a:r>
-              <a:t>Think Deeper manuellement</a:t>
-            </a:r>
-          </a:p>
-        </p:txBody>
-      </p:sp>
-      <p:sp>
-        <p:nvSpPr>
-          <p:cNvPr id="8" name="Rectangle 7"/>
-          <p:cNvSpPr/>
-          <p:nvPr/>
-        </p:nvSpPr>
-        <p:spPr>
-          <a:xfrm>
-            <a:off x="4114800" y="1463040"/>
-            <a:ext cx="3383280" cy="4754880"/>
-          </a:xfrm>
-          <a:prstGeom prst="rect">
-            <a:avLst/>
-          </a:prstGeom>
-          <a:solidFill>
-            <a:srgbClr val="FFFFFF"/>
-          </a:solidFill>
-          <a:ln>
-            <a:solidFill>
-              <a:srgbClr val="E0E0E0"/>
-            </a:solidFill>
-          </a:ln>
-          <a:effectLst/>
-        </p:spPr>
-        <p:style>
-          <a:lnRef idx="1">
-            <a:schemeClr val="accent1"/>
-          </a:lnRef>
-          <a:fillRef idx="3">
-            <a:schemeClr val="accent1"/>
-          </a:fillRef>
-          <a:effectRef idx="2">
-            <a:schemeClr val="accent1"/>
-          </a:effectRef>
-          <a:fontRef idx="minor">
-            <a:schemeClr val="lt1"/>
-          </a:fontRef>
-        </p:style>
-        <p:txBody>
-          <a:bodyPr rtlCol="0" anchor="ctr"/>
-          <a:lstStyle/>
-          <a:p>
-            <a:pPr algn="ctr"/>
-          </a:p>
-        </p:txBody>
-      </p:sp>
-      <p:pic>
-        <p:nvPicPr>
-          <p:cNvPr id="9" name="Picture 8" descr="lightbulb_00874E_30.png"/>
-          <p:cNvPicPr>
-            <a:picLocks noChangeAspect="1"/>
-          </p:cNvPicPr>
-          <p:nvPr/>
-        </p:nvPicPr>
-        <p:blipFill>
-          <a:blip r:embed="rId3"/>
-          <a:stretch>
-            <a:fillRect/>
-          </a:stretch>
-        </p:blipFill>
-        <p:spPr>
-          <a:xfrm>
-            <a:off x="4370832" y="1627632"/>
-            <a:ext cx="292608" cy="292608"/>
-          </a:xfrm>
-          <a:prstGeom prst="rect">
-            <a:avLst/>
-          </a:prstGeom>
-        </p:spPr>
-      </p:pic>
-      <p:sp>
-        <p:nvSpPr>
-          <p:cNvPr id="10" name="TextBox 9"/>
-          <p:cNvSpPr txBox="1"/>
-          <p:nvPr/>
-        </p:nvSpPr>
-        <p:spPr>
-          <a:xfrm>
-            <a:off x="4773168" y="1645920"/>
-            <a:ext cx="2542031" cy="457200"/>
-          </a:xfrm>
-          <a:prstGeom prst="rect">
-            <a:avLst/>
-          </a:prstGeom>
-          <a:noFill/>
-        </p:spPr>
-        <p:txBody>
-          <a:bodyPr wrap="square" lIns="45720" rIns="45720" tIns="18288" bIns="18288">
-            <a:spAutoFit/>
-          </a:bodyPr>
-          <a:lstStyle/>
-          <a:p>
-            <a:pPr algn="l">
-              <a:defRPr sz="1700" b="1">
-                <a:solidFill>
-                  <a:srgbClr val="00874E"/>
-                </a:solidFill>
-                <a:latin typeface="Calibri"/>
-              </a:defRPr>
-            </a:pPr>
-            <a:r>
-              <a:t>Astuce 2</a:t>
-            </a:r>
-          </a:p>
-        </p:txBody>
-      </p:sp>
-      <p:sp>
-        <p:nvSpPr>
-          <p:cNvPr id="11" name="TextBox 10"/>
-          <p:cNvSpPr txBox="1"/>
-          <p:nvPr/>
-        </p:nvSpPr>
-        <p:spPr>
-          <a:xfrm>
-            <a:off x="4389120" y="2240280"/>
-            <a:ext cx="2834640" cy="3794760"/>
-          </a:xfrm>
-          <a:prstGeom prst="rect">
-            <a:avLst/>
-          </a:prstGeom>
-          <a:noFill/>
-        </p:spPr>
-        <p:txBody>
-          <a:bodyPr wrap="square">
-            <a:spAutoFit/>
-          </a:bodyPr>
-          <a:lstStyle/>
-          <a:p>
-            <a:pPr>
-              <a:spcAft>
-                <a:spcPts val="400"/>
-              </a:spcAft>
-              <a:defRPr sz="1300">
-                <a:solidFill>
-                  <a:srgbClr val="2B2B2B"/>
-                </a:solidFill>
-                <a:latin typeface="Calibri"/>
-              </a:defRPr>
-            </a:pPr>
-            <a:r>
-              <a:t>En institution financière,</a:t>
-            </a:r>
-          </a:p>
-          <a:p>
-            <a:pPr>
-              <a:spcAft>
-                <a:spcPts val="400"/>
-              </a:spcAft>
-              <a:defRPr sz="1300">
-                <a:solidFill>
-                  <a:srgbClr val="2B2B2B"/>
-                </a:solidFill>
-                <a:latin typeface="Calibri"/>
-              </a:defRPr>
-            </a:pPr>
-            <a:r>
-              <a:t>utilisez Think Deeper pour</a:t>
-            </a:r>
-          </a:p>
-          <a:p>
-            <a:pPr>
-              <a:spcAft>
-                <a:spcPts val="400"/>
-              </a:spcAft>
-              <a:defRPr sz="1300">
-                <a:solidFill>
-                  <a:srgbClr val="2B2B2B"/>
-                </a:solidFill>
-                <a:latin typeface="Calibri"/>
-              </a:defRPr>
-            </a:pPr>
-            <a:r>
-              <a:t>toute analyse impliquant</a:t>
-            </a:r>
-          </a:p>
-          <a:p>
-            <a:pPr>
-              <a:spcAft>
-                <a:spcPts val="400"/>
-              </a:spcAft>
-              <a:defRPr sz="1300">
-                <a:solidFill>
-                  <a:srgbClr val="2B2B2B"/>
-                </a:solidFill>
-                <a:latin typeface="Calibri"/>
-              </a:defRPr>
-            </a:pPr>
-            <a:r>
-              <a:t>des données sensibles</a:t>
-            </a:r>
-          </a:p>
-        </p:txBody>
-      </p:sp>
-      <p:sp>
-        <p:nvSpPr>
-          <p:cNvPr id="12" name="Rectangle 11"/>
-          <p:cNvSpPr/>
-          <p:nvPr/>
-        </p:nvSpPr>
-        <p:spPr>
-          <a:xfrm>
-            <a:off x="7772400" y="1463040"/>
-            <a:ext cx="3383280" cy="4754880"/>
-          </a:xfrm>
-          <a:prstGeom prst="rect">
-            <a:avLst/>
-          </a:prstGeom>
-          <a:solidFill>
-            <a:srgbClr val="FFFFFF"/>
-          </a:solidFill>
-          <a:ln>
-            <a:solidFill>
-              <a:srgbClr val="E0E0E0"/>
-            </a:solidFill>
-          </a:ln>
-          <a:effectLst/>
-        </p:spPr>
-        <p:style>
-          <a:lnRef idx="1">
-            <a:schemeClr val="accent1"/>
-          </a:lnRef>
-          <a:fillRef idx="3">
-            <a:schemeClr val="accent1"/>
-          </a:fillRef>
-          <a:effectRef idx="2">
-            <a:schemeClr val="accent1"/>
-          </a:effectRef>
-          <a:fontRef idx="minor">
-            <a:schemeClr val="lt1"/>
-          </a:fontRef>
-        </p:style>
-        <p:txBody>
-          <a:bodyPr rtlCol="0" anchor="ctr"/>
-          <a:lstStyle/>
-          <a:p>
-            <a:pPr algn="ctr"/>
-          </a:p>
-        </p:txBody>
-      </p:sp>
-      <p:pic>
-        <p:nvPicPr>
-          <p:cNvPr id="13" name="Picture 12" descr="lightbulb_F59E0B_30.png"/>
-          <p:cNvPicPr>
-            <a:picLocks noChangeAspect="1"/>
-          </p:cNvPicPr>
-          <p:nvPr/>
-        </p:nvPicPr>
-        <p:blipFill>
-          <a:blip r:embed="rId4"/>
-          <a:stretch>
-            <a:fillRect/>
-          </a:stretch>
-        </p:blipFill>
-        <p:spPr>
-          <a:xfrm>
-            <a:off x="8028431" y="1627632"/>
-            <a:ext cx="292608" cy="292608"/>
-          </a:xfrm>
-          <a:prstGeom prst="rect">
-            <a:avLst/>
-          </a:prstGeom>
-        </p:spPr>
-      </p:pic>
-      <p:sp>
-        <p:nvSpPr>
-          <p:cNvPr id="14" name="TextBox 13"/>
-          <p:cNvSpPr txBox="1"/>
-          <p:nvPr/>
-        </p:nvSpPr>
-        <p:spPr>
-          <a:xfrm>
-            <a:off x="8430767" y="1645920"/>
-            <a:ext cx="2542032" cy="457200"/>
-          </a:xfrm>
-          <a:prstGeom prst="rect">
-            <a:avLst/>
-          </a:prstGeom>
-          <a:noFill/>
-        </p:spPr>
-        <p:txBody>
-          <a:bodyPr wrap="square" lIns="45720" rIns="45720" tIns="18288" bIns="18288">
-            <a:spAutoFit/>
-          </a:bodyPr>
-          <a:lstStyle/>
-          <a:p>
-            <a:pPr algn="l">
-              <a:defRPr sz="1700" b="1">
-                <a:solidFill>
-                  <a:srgbClr val="F59E0B"/>
-                </a:solidFill>
-                <a:latin typeface="Calibri"/>
-              </a:defRPr>
-            </a:pPr>
-            <a:r>
-              <a:t>Astuce 3</a:t>
-            </a:r>
-          </a:p>
-        </p:txBody>
-      </p:sp>
-      <p:sp>
-        <p:nvSpPr>
-          <p:cNvPr id="15" name="TextBox 14"/>
-          <p:cNvSpPr txBox="1"/>
-          <p:nvPr/>
-        </p:nvSpPr>
-        <p:spPr>
-          <a:xfrm>
-            <a:off x="8046720" y="2240280"/>
-            <a:ext cx="2834640" cy="3794760"/>
-          </a:xfrm>
-          <a:prstGeom prst="rect">
-            <a:avLst/>
-          </a:prstGeom>
-          <a:noFill/>
-        </p:spPr>
-        <p:txBody>
-          <a:bodyPr wrap="square">
-            <a:spAutoFit/>
-          </a:bodyPr>
-          <a:lstStyle/>
-          <a:p>
-            <a:pPr>
-              <a:spcAft>
-                <a:spcPts val="400"/>
-              </a:spcAft>
-              <a:defRPr sz="1300">
-                <a:solidFill>
-                  <a:srgbClr val="2B2B2B"/>
-                </a:solidFill>
-                <a:latin typeface="Calibri"/>
-              </a:defRPr>
-            </a:pPr>
-            <a:r>
-              <a:t>Quick Response pour les</a:t>
-            </a:r>
-          </a:p>
-          <a:p>
-            <a:pPr>
-              <a:spcAft>
-                <a:spcPts val="400"/>
-              </a:spcAft>
-              <a:defRPr sz="1300">
-                <a:solidFill>
-                  <a:srgbClr val="2B2B2B"/>
-                </a:solidFill>
-                <a:latin typeface="Calibri"/>
-              </a:defRPr>
-            </a:pPr>
-            <a:r>
-              <a:t>courriels, Auto pour le</a:t>
-            </a:r>
-          </a:p>
-          <a:p>
-            <a:pPr>
-              <a:spcAft>
-                <a:spcPts val="400"/>
-              </a:spcAft>
-              <a:defRPr sz="1300">
-                <a:solidFill>
-                  <a:srgbClr val="2B2B2B"/>
-                </a:solidFill>
-                <a:latin typeface="Calibri"/>
-              </a:defRPr>
-            </a:pPr>
-            <a:r>
-              <a:t>reste. Vous gagnerez</a:t>
-            </a:r>
-          </a:p>
-          <a:p>
-            <a:pPr>
-              <a:spcAft>
-                <a:spcPts val="400"/>
-              </a:spcAft>
-              <a:defRPr sz="1300">
-                <a:solidFill>
-                  <a:srgbClr val="2B2B2B"/>
-                </a:solidFill>
-                <a:latin typeface="Calibri"/>
-              </a:defRPr>
-            </a:pPr>
-            <a:r>
-              <a:t>du temps chaque jour!</a:t>
-            </a:r>
-          </a:p>
-        </p:txBody>
-      </p:sp>
-      <p:sp>
-        <p:nvSpPr>
-          <p:cNvPr id="16" name="Rectangle 15"/>
-          <p:cNvSpPr/>
-          <p:nvPr/>
-        </p:nvSpPr>
-        <p:spPr>
-          <a:xfrm>
-            <a:off x="457200" y="6446520"/>
-            <a:ext cx="11274552" cy="13716"/>
-          </a:xfrm>
-          <a:prstGeom prst="rect">
-            <a:avLst/>
-          </a:prstGeom>
-          <a:solidFill>
-            <a:srgbClr val="00874E"/>
-          </a:solidFill>
-          <a:ln>
-            <a:noFill/>
-          </a:ln>
-          <a:effectLst/>
-        </p:spPr>
-        <p:style>
-          <a:lnRef idx="1">
-            <a:schemeClr val="accent1"/>
-          </a:lnRef>
-          <a:fillRef idx="3">
-            <a:schemeClr val="accent1"/>
-          </a:fillRef>
-          <a:effectRef idx="2">
-            <a:schemeClr val="accent1"/>
-          </a:effectRef>
-          <a:fontRef idx="minor">
-            <a:schemeClr val="lt1"/>
-          </a:fontRef>
-        </p:style>
-        <p:txBody>
-          <a:bodyPr rtlCol="0" anchor="ctr"/>
-          <a:lstStyle/>
-          <a:p>
-            <a:pPr algn="ctr"/>
-          </a:p>
-        </p:txBody>
-      </p:sp>
-      <p:sp>
-        <p:nvSpPr>
-          <p:cNvPr id="17" name="TextBox 16"/>
-          <p:cNvSpPr txBox="1"/>
-          <p:nvPr/>
-        </p:nvSpPr>
-        <p:spPr>
-          <a:xfrm>
-            <a:off x="457200" y="6537960"/>
-            <a:ext cx="5486400" cy="274320"/>
-          </a:xfrm>
-          <a:prstGeom prst="rect">
-            <a:avLst/>
-          </a:prstGeom>
-          <a:noFill/>
-        </p:spPr>
-        <p:txBody>
-          <a:bodyPr wrap="square" lIns="45720" rIns="45720" tIns="18288" bIns="18288">
-            <a:spAutoFit/>
-          </a:bodyPr>
-          <a:lstStyle/>
-          <a:p>
-            <a:pPr algn="l">
-              <a:defRPr sz="1000" b="0">
-                <a:solidFill>
-                  <a:srgbClr val="6B6B6B"/>
-                </a:solidFill>
-                <a:latin typeface="Calibri"/>
-              </a:defRPr>
-            </a:pPr>
-            <a:r>
-              <a:t>La minute Copilot</a:t>
-            </a:r>
-          </a:p>
-        </p:txBody>
-      </p:sp>
-      <p:sp>
-        <p:nvSpPr>
-          <p:cNvPr id="18" name="TextBox 17"/>
-          <p:cNvSpPr txBox="1"/>
-          <p:nvPr/>
-        </p:nvSpPr>
-        <p:spPr>
-          <a:xfrm>
-            <a:off x="10972800" y="6537960"/>
-            <a:ext cx="822960" cy="274320"/>
-          </a:xfrm>
-          <a:prstGeom prst="rect">
-            <a:avLst/>
-          </a:prstGeom>
-          <a:noFill/>
-        </p:spPr>
-        <p:txBody>
-          <a:bodyPr wrap="square" lIns="45720" rIns="45720" tIns="18288" bIns="18288">
-            <a:spAutoFit/>
-          </a:bodyPr>
-          <a:lstStyle/>
-          <a:p>
-            <a:pPr algn="r">
-              <a:defRPr sz="1000" b="0">
-                <a:solidFill>
-                  <a:srgbClr val="6B6B6B"/>
-                </a:solidFill>
-                <a:latin typeface="Calibri"/>
-              </a:defRPr>
-            </a:pPr>
-            <a:r>
-              <a:t>5</a:t>
-            </a:r>
-          </a:p>
-        </p:txBody>
-      </p:sp>
-    </p:spTree>
-  </p:cSld>
-  <p:clrMapOvr>
-    <a:masterClrMapping/>
-  </p:clrMapOvr>
-</p:sld>
-</file>
-
-<file path=ppt/slides/slide6.xml><?xml version="1.0" encoding="utf-8"?>
 <p:sld xmlns:a="http://schemas.openxmlformats.org/drawingml/2006/main" xmlns:p="http://schemas.openxmlformats.org/presentationml/2006/main" xmlns:r="http://schemas.openxmlformats.org/officeDocument/2006/relationships">
   <p:cSld>
     <p:bg>
@@ -8207,7 +7263,7 @@
               </a:defRPr>
             </a:pPr>
             <a:r>
-              <a:t>À retenir — Les modèles Copilot</a:t>
+              <a:t>À retenir — Les modes Copilot</a:t>
             </a:r>
           </a:p>
         </p:txBody>
@@ -8393,11 +7449,11 @@
               </a:defRPr>
             </a:pPr>
             <a:r>
-              <a:t>80% du temps</a:t>
+              <a:t>Copilot choisit</a:t>
             </a:r>
             <a:br/>
             <a:r>
-              <a:t>Copilot choisit pour vous</a:t>
+              <a:t>pour vous</a:t>
             </a:r>
           </a:p>
         </p:txBody>
@@ -8543,7 +7599,7 @@
             </a:r>
             <a:br/>
             <a:r>
-              <a:t>Courriels, résumés</a:t>
+              <a:t>Réponse en secondes</a:t>
             </a:r>
           </a:p>
         </p:txBody>
@@ -8685,11 +7741,11 @@
               </a:defRPr>
             </a:pPr>
             <a:r>
-              <a:t>Analyse complexe</a:t>
+              <a:t>Analyse, conformité</a:t>
             </a:r>
             <a:br/>
             <a:r>
-              <a:t>Code, risques, conformité</a:t>
+              <a:t>30–90 s. Ça vaut l'attente</a:t>
             </a:r>
           </a:p>
         </p:txBody>
@@ -8815,7 +7871,7 @@
               </a:defRPr>
             </a:pPr>
             <a:r>
-              <a:t>Défi: Essayez Think Deeper sur votre prochaine tâche complexe!</a:t>
+              <a:t>Défi: Essayez Think Deeper sur votre prochaine analyse de conformité ou de risques!</a:t>
             </a:r>
           </a:p>
         </p:txBody>

</xml_diff>